<commit_message>
Add Data Quality Score, Before/After Compare tab, Operation History
</commit_message>
<xml_diff>
--- a/presentation.pptx
+++ b/presentation.pptx
@@ -14,6 +14,7 @@
     <p:sldId id="262" r:id="rId13"/>
     <p:sldId id="263" r:id="rId14"/>
     <p:sldId id="264" r:id="rId15"/>
+    <p:sldId id="265" r:id="rId16"/>
   </p:sldIdLst>
   <p:sldSz cx="12191695" cy="6858000" type="screen4x3"/>
   <p:notesSz cx="6858000" cy="9144000"/>
@@ -3159,6 +3160,84 @@
 </p:sld>
 </file>
 
+<file path=ppt/slides/slide10.xml><?xml version="1.0" encoding="utf-8"?>
+<p:sld xmlns:a="http://schemas.openxmlformats.org/drawingml/2006/main" xmlns:p="http://schemas.openxmlformats.org/presentationml/2006/main" xmlns:r="http://schemas.openxmlformats.org/officeDocument/2006/relationships">
+  <p:cSld>
+    <p:bg>
+      <p:bgPr>
+        <a:solidFill>
+          <a:srgbClr val="1E1E2E"/>
+        </a:solidFill>
+        <a:effectLst/>
+      </p:bgPr>
+    </p:bg>
+    <p:spTree>
+      <p:nvGrpSpPr>
+        <p:cNvPr id="1" name=""/>
+        <p:cNvGrpSpPr/>
+        <p:nvPr/>
+      </p:nvGrpSpPr>
+      <p:grpSpPr/>
+      <p:sp>
+        <p:nvSpPr>
+          <p:cNvPr id="2" name="TextBox 1"/>
+          <p:cNvSpPr txBox="1"/>
+          <p:nvPr/>
+        </p:nvSpPr>
+        <p:spPr>
+          <a:xfrm>
+            <a:off x="914400" y="2286000"/>
+            <a:ext cx="10058400" cy="1828800"/>
+          </a:xfrm>
+          <a:prstGeom prst="rect">
+            <a:avLst/>
+          </a:prstGeom>
+          <a:noFill/>
+        </p:spPr>
+        <p:txBody>
+          <a:bodyPr wrap="none">
+            <a:spAutoFit/>
+          </a:bodyPr>
+          <a:lstStyle/>
+          <a:p>
+            <a:pPr algn="ctr">
+              <a:defRPr sz="4400" b="1">
+                <a:solidFill>
+                  <a:srgbClr val="FFFFFF"/>
+                </a:solidFill>
+              </a:defRPr>
+            </a:pPr>
+            <a:r>
+              <a:t>Thank You! 🎉</a:t>
+            </a:r>
+          </a:p>
+          <a:p>
+            <a:pPr algn="ctr">
+              <a:defRPr sz="2200">
+                <a:solidFill>
+                  <a:srgbClr val="BAC2DE"/>
+                </a:solidFill>
+              </a:defRPr>
+            </a:pPr>
+            <a:r>
+              <a:t>64 operations • 14 categories • 1 app</a:t>
+            </a:r>
+            <a:br/>
+            <a:br/>
+            <a:r>
+              <a:t>Questions?</a:t>
+            </a:r>
+          </a:p>
+        </p:txBody>
+      </p:sp>
+    </p:spTree>
+  </p:cSld>
+  <p:clrMapOvr>
+    <a:masterClrMapping/>
+  </p:clrMapOvr>
+</p:sld>
+</file>
+
 <file path=ppt/slides/slide2.xml><?xml version="1.0" encoding="utf-8"?>
 <p:sld xmlns:a="http://schemas.openxmlformats.org/drawingml/2006/main" xmlns:p="http://schemas.openxmlformats.org/presentationml/2006/main" xmlns:r="http://schemas.openxmlformats.org/officeDocument/2006/relationships">
   <p:cSld>
@@ -4390,106 +4469,121 @@
               </a:defRPr>
             </a:pPr>
             <a:r>
-              <a:t>📊 Live Preview &amp; Download</a:t>
-            </a:r>
-          </a:p>
-          <a:p>
-            <a:pPr>
-              <a:spcAft>
-                <a:spcPts val="1000"/>
-              </a:spcAft>
-              <a:defRPr sz="2000">
-                <a:solidFill>
-                  <a:srgbClr val="FFFFFF"/>
-                </a:solidFill>
-              </a:defRPr>
-            </a:pPr>
-            <a:r>
-              <a:t>   → See processed data instantly, export CSV anytime</a:t>
-            </a:r>
-          </a:p>
-          <a:p>
-            <a:pPr>
-              <a:spcAft>
-                <a:spcPts val="1000"/>
-              </a:spcAft>
-              <a:defRPr sz="2000">
-                <a:solidFill>
-                  <a:srgbClr val="FFFFFF"/>
-                </a:solidFill>
-              </a:defRPr>
-            </a:pPr>
-          </a:p>
-          <a:p>
-            <a:pPr>
-              <a:spcAft>
-                <a:spcPts val="1000"/>
-              </a:spcAft>
-              <a:defRPr sz="2000">
-                <a:solidFill>
-                  <a:srgbClr val="FFFFFF"/>
-                </a:solidFill>
-              </a:defRPr>
-            </a:pPr>
-            <a:r>
-              <a:t>🧪 64 Automated Tests — All Passing</a:t>
-            </a:r>
-          </a:p>
-          <a:p>
-            <a:pPr>
-              <a:spcAft>
-                <a:spcPts val="1000"/>
-              </a:spcAft>
-              <a:defRPr sz="2000">
-                <a:solidFill>
-                  <a:srgbClr val="FFFFFF"/>
-                </a:solidFill>
-              </a:defRPr>
-            </a:pPr>
-            <a:r>
-              <a:t>   → Validates every function with edge cases (NaN, outliers, duplicates)</a:t>
-            </a:r>
-          </a:p>
-          <a:p>
-            <a:pPr>
-              <a:spcAft>
-                <a:spcPts val="1000"/>
-              </a:spcAft>
-              <a:defRPr sz="2000">
-                <a:solidFill>
-                  <a:srgbClr val="FFFFFF"/>
-                </a:solidFill>
-              </a:defRPr>
-            </a:pPr>
-          </a:p>
-          <a:p>
-            <a:pPr>
-              <a:spcAft>
-                <a:spcPts val="1000"/>
-              </a:spcAft>
-              <a:defRPr sz="2000">
-                <a:solidFill>
-                  <a:srgbClr val="FFFFFF"/>
-                </a:solidFill>
-              </a:defRPr>
-            </a:pPr>
-            <a:r>
-              <a:t>🛡️ Robust Error Handling</a:t>
-            </a:r>
-          </a:p>
-          <a:p>
-            <a:pPr>
-              <a:spcAft>
-                <a:spcPts val="1000"/>
-              </a:spcAft>
-              <a:defRPr sz="2000">
-                <a:solidFill>
-                  <a:srgbClr val="FFFFFF"/>
-                </a:solidFill>
-              </a:defRPr>
-            </a:pPr>
-            <a:r>
-              <a:t>   → Auto-adjusts SMOTE k_neighbors, handles NaN in sklearn transforms</a:t>
+              <a:t>📊 Data Quality Score (0-100)</a:t>
+            </a:r>
+          </a:p>
+          <a:p>
+            <a:pPr>
+              <a:spcAft>
+                <a:spcPts val="1000"/>
+              </a:spcAft>
+              <a:defRPr sz="2000">
+                <a:solidFill>
+                  <a:srgbClr val="FFFFFF"/>
+                </a:solidFill>
+              </a:defRPr>
+            </a:pPr>
+            <a:r>
+              <a:t>   → Completeness, Uniqueness, Consistency, Validity</a:t>
+            </a:r>
+          </a:p>
+          <a:p>
+            <a:pPr>
+              <a:spcAft>
+                <a:spcPts val="1000"/>
+              </a:spcAft>
+              <a:defRPr sz="2000">
+                <a:solidFill>
+                  <a:srgbClr val="FFFFFF"/>
+                </a:solidFill>
+              </a:defRPr>
+            </a:pPr>
+            <a:r>
+              <a:t>   → Color-coded: 🟢 ≥80  🟡 ≥60  🔴 &lt;60</a:t>
+            </a:r>
+          </a:p>
+          <a:p>
+            <a:pPr>
+              <a:spcAft>
+                <a:spcPts val="1000"/>
+              </a:spcAft>
+              <a:defRPr sz="2000">
+                <a:solidFill>
+                  <a:srgbClr val="FFFFFF"/>
+                </a:solidFill>
+              </a:defRPr>
+            </a:pPr>
+          </a:p>
+          <a:p>
+            <a:pPr>
+              <a:spcAft>
+                <a:spcPts val="1000"/>
+              </a:spcAft>
+              <a:defRPr sz="2000">
+                <a:solidFill>
+                  <a:srgbClr val="FFFFFF"/>
+                </a:solidFill>
+              </a:defRPr>
+            </a:pPr>
+            <a:r>
+              <a:t>📈 Before/After Compare Tab</a:t>
+            </a:r>
+          </a:p>
+          <a:p>
+            <a:pPr>
+              <a:spcAft>
+                <a:spcPts val="1000"/>
+              </a:spcAft>
+              <a:defRPr sz="2000">
+                <a:solidFill>
+                  <a:srgbClr val="FFFFFF"/>
+                </a:solidFill>
+              </a:defRPr>
+            </a:pPr>
+            <a:r>
+              <a:t>   → Side-by-side distribution plots, stats delta, quality score change</a:t>
+            </a:r>
+          </a:p>
+          <a:p>
+            <a:pPr>
+              <a:spcAft>
+                <a:spcPts val="1000"/>
+              </a:spcAft>
+              <a:defRPr sz="2000">
+                <a:solidFill>
+                  <a:srgbClr val="FFFFFF"/>
+                </a:solidFill>
+              </a:defRPr>
+            </a:pPr>
+          </a:p>
+          <a:p>
+            <a:pPr>
+              <a:spcAft>
+                <a:spcPts val="1000"/>
+              </a:spcAft>
+              <a:defRPr sz="2000">
+                <a:solidFill>
+                  <a:srgbClr val="FFFFFF"/>
+                </a:solidFill>
+              </a:defRPr>
+            </a:pPr>
+            <a:r>
+              <a:t>🕐 Operation History</a:t>
+            </a:r>
+          </a:p>
+          <a:p>
+            <a:pPr>
+              <a:spcAft>
+                <a:spcPts val="1000"/>
+              </a:spcAft>
+              <a:defRPr sz="2000">
+                <a:solidFill>
+                  <a:srgbClr val="FFFFFF"/>
+                </a:solidFill>
+              </a:defRPr>
+            </a:pPr>
+            <a:r>
+              <a:t>   → Every action logged, full audit trail, reset anytime</a:t>
             </a:r>
           </a:p>
         </p:txBody>
@@ -4550,7 +4644,7 @@
               </a:defRPr>
             </a:pPr>
             <a:r>
-              <a:t>How to Run</a:t>
+              <a:t>Key Features — continued</a:t>
             </a:r>
           </a:p>
         </p:txBody>
@@ -4588,94 +4682,148 @@
               </a:defRPr>
             </a:pPr>
             <a:r>
-              <a:t>$ cd alpha_Hackathon</a:t>
-            </a:r>
-          </a:p>
-          <a:p>
-            <a:pPr>
-              <a:spcAft>
-                <a:spcPts val="1000"/>
-              </a:spcAft>
-              <a:defRPr sz="2000">
-                <a:solidFill>
-                  <a:srgbClr val="FFFFFF"/>
-                </a:solidFill>
-              </a:defRPr>
-            </a:pPr>
-            <a:r>
-              <a:t>$ python3 -m venv venv</a:t>
-            </a:r>
-          </a:p>
-          <a:p>
-            <a:pPr>
-              <a:spcAft>
-                <a:spcPts val="1000"/>
-              </a:spcAft>
-              <a:defRPr sz="2000">
-                <a:solidFill>
-                  <a:srgbClr val="FFFFFF"/>
-                </a:solidFill>
-              </a:defRPr>
-            </a:pPr>
-            <a:r>
-              <a:t>$ source venv/bin/activate</a:t>
-            </a:r>
-          </a:p>
-          <a:p>
-            <a:pPr>
-              <a:spcAft>
-                <a:spcPts val="1000"/>
-              </a:spcAft>
-              <a:defRPr sz="2000">
-                <a:solidFill>
-                  <a:srgbClr val="FFFFFF"/>
-                </a:solidFill>
-              </a:defRPr>
-            </a:pPr>
-            <a:r>
-              <a:t>$ pip install -r requirements.txt</a:t>
-            </a:r>
-          </a:p>
-          <a:p>
-            <a:pPr>
-              <a:spcAft>
-                <a:spcPts val="1000"/>
-              </a:spcAft>
-              <a:defRPr sz="2000">
-                <a:solidFill>
-                  <a:srgbClr val="FFFFFF"/>
-                </a:solidFill>
-              </a:defRPr>
-            </a:pPr>
-            <a:r>
-              <a:t>$ streamlit run app.py</a:t>
-            </a:r>
-          </a:p>
-          <a:p>
-            <a:pPr>
-              <a:spcAft>
-                <a:spcPts val="1000"/>
-              </a:spcAft>
-              <a:defRPr sz="2000">
-                <a:solidFill>
-                  <a:srgbClr val="FFFFFF"/>
-                </a:solidFill>
-              </a:defRPr>
-            </a:pPr>
-          </a:p>
-          <a:p>
-            <a:pPr>
-              <a:spcAft>
-                <a:spcPts val="1000"/>
-              </a:spcAft>
-              <a:defRPr sz="2000">
-                <a:solidFill>
-                  <a:srgbClr val="FFFFFF"/>
-                </a:solidFill>
-              </a:defRPr>
-            </a:pPr>
-            <a:r>
-              <a:t>Then upload sample_data.csv (or any dataset) to start processing!</a:t>
+              <a:t>📊 Live Preview &amp; Download</a:t>
+            </a:r>
+          </a:p>
+          <a:p>
+            <a:pPr>
+              <a:spcAft>
+                <a:spcPts val="1000"/>
+              </a:spcAft>
+              <a:defRPr sz="2000">
+                <a:solidFill>
+                  <a:srgbClr val="FFFFFF"/>
+                </a:solidFill>
+              </a:defRPr>
+            </a:pPr>
+            <a:r>
+              <a:t>   → See processed data instantly, export CSV anytime</a:t>
+            </a:r>
+          </a:p>
+          <a:p>
+            <a:pPr>
+              <a:spcAft>
+                <a:spcPts val="1000"/>
+              </a:spcAft>
+              <a:defRPr sz="2000">
+                <a:solidFill>
+                  <a:srgbClr val="FFFFFF"/>
+                </a:solidFill>
+              </a:defRPr>
+            </a:pPr>
+          </a:p>
+          <a:p>
+            <a:pPr>
+              <a:spcAft>
+                <a:spcPts val="1000"/>
+              </a:spcAft>
+              <a:defRPr sz="2000">
+                <a:solidFill>
+                  <a:srgbClr val="FFFFFF"/>
+                </a:solidFill>
+              </a:defRPr>
+            </a:pPr>
+            <a:r>
+              <a:t>🧪 64 Automated Tests — All Passing</a:t>
+            </a:r>
+          </a:p>
+          <a:p>
+            <a:pPr>
+              <a:spcAft>
+                <a:spcPts val="1000"/>
+              </a:spcAft>
+              <a:defRPr sz="2000">
+                <a:solidFill>
+                  <a:srgbClr val="FFFFFF"/>
+                </a:solidFill>
+              </a:defRPr>
+            </a:pPr>
+            <a:r>
+              <a:t>   → Validates every function with edge cases (NaN, outliers, duplicates)</a:t>
+            </a:r>
+          </a:p>
+          <a:p>
+            <a:pPr>
+              <a:spcAft>
+                <a:spcPts val="1000"/>
+              </a:spcAft>
+              <a:defRPr sz="2000">
+                <a:solidFill>
+                  <a:srgbClr val="FFFFFF"/>
+                </a:solidFill>
+              </a:defRPr>
+            </a:pPr>
+          </a:p>
+          <a:p>
+            <a:pPr>
+              <a:spcAft>
+                <a:spcPts val="1000"/>
+              </a:spcAft>
+              <a:defRPr sz="2000">
+                <a:solidFill>
+                  <a:srgbClr val="FFFFFF"/>
+                </a:solidFill>
+              </a:defRPr>
+            </a:pPr>
+            <a:r>
+              <a:t>🛡️ Robust Error Handling</a:t>
+            </a:r>
+          </a:p>
+          <a:p>
+            <a:pPr>
+              <a:spcAft>
+                <a:spcPts val="1000"/>
+              </a:spcAft>
+              <a:defRPr sz="2000">
+                <a:solidFill>
+                  <a:srgbClr val="FFFFFF"/>
+                </a:solidFill>
+              </a:defRPr>
+            </a:pPr>
+            <a:r>
+              <a:t>   → Auto-adjusts SMOTE k_neighbors, handles NaN in sklearn transforms</a:t>
+            </a:r>
+          </a:p>
+          <a:p>
+            <a:pPr>
+              <a:spcAft>
+                <a:spcPts val="1000"/>
+              </a:spcAft>
+              <a:defRPr sz="2000">
+                <a:solidFill>
+                  <a:srgbClr val="FFFFFF"/>
+                </a:solidFill>
+              </a:defRPr>
+            </a:pPr>
+          </a:p>
+          <a:p>
+            <a:pPr>
+              <a:spcAft>
+                <a:spcPts val="1000"/>
+              </a:spcAft>
+              <a:defRPr sz="2000">
+                <a:solidFill>
+                  <a:srgbClr val="FFFFFF"/>
+                </a:solidFill>
+              </a:defRPr>
+            </a:pPr>
+            <a:r>
+              <a:t>🐳 Docker Support</a:t>
+            </a:r>
+          </a:p>
+          <a:p>
+            <a:pPr>
+              <a:spcAft>
+                <a:spcPts val="1000"/>
+              </a:spcAft>
+              <a:defRPr sz="2000">
+                <a:solidFill>
+                  <a:srgbClr val="FFFFFF"/>
+                </a:solidFill>
+              </a:defRPr>
+            </a:pPr>
+            <a:r>
+              <a:t>   → One command: docker compose up --build</a:t>
             </a:r>
           </a:p>
         </p:txBody>
@@ -4736,7 +4884,7 @@
               </a:defRPr>
             </a:pPr>
             <a:r>
-              <a:t>Future Enhancements</a:t>
+              <a:t>How to Run</a:t>
             </a:r>
           </a:p>
         </p:txBody>
@@ -4774,82 +4922,94 @@
               </a:defRPr>
             </a:pPr>
             <a:r>
-              <a:t>• Pipeline export — save &amp; replay processing steps as JSON</a:t>
-            </a:r>
-          </a:p>
-          <a:p>
-            <a:pPr>
-              <a:spcAft>
-                <a:spcPts val="1000"/>
-              </a:spcAft>
-              <a:defRPr sz="2000">
-                <a:solidFill>
-                  <a:srgbClr val="FFFFFF"/>
-                </a:solidFill>
-              </a:defRPr>
-            </a:pPr>
-            <a:r>
-              <a:t>• AutoML integration — auto-suggest preprocessing per column type</a:t>
-            </a:r>
-          </a:p>
-          <a:p>
-            <a:pPr>
-              <a:spcAft>
-                <a:spcPts val="1000"/>
-              </a:spcAft>
-              <a:defRPr sz="2000">
-                <a:solidFill>
-                  <a:srgbClr val="FFFFFF"/>
-                </a:solidFill>
-              </a:defRPr>
-            </a:pPr>
-            <a:r>
-              <a:t>• UMAP &amp; Autoencoder for dimensionality reduction</a:t>
-            </a:r>
-          </a:p>
-          <a:p>
-            <a:pPr>
-              <a:spcAft>
-                <a:spcPts val="1000"/>
-              </a:spcAft>
-              <a:defRPr sz="2000">
-                <a:solidFill>
-                  <a:srgbClr val="FFFFFF"/>
-                </a:solidFill>
-              </a:defRPr>
-            </a:pPr>
-            <a:r>
-              <a:t>• NLP: stopword removal, TF-IDF, embeddings</a:t>
-            </a:r>
-          </a:p>
-          <a:p>
-            <a:pPr>
-              <a:spcAft>
-                <a:spcPts val="1000"/>
-              </a:spcAft>
-              <a:defRPr sz="2000">
-                <a:solidFill>
-                  <a:srgbClr val="FFFFFF"/>
-                </a:solidFill>
-              </a:defRPr>
-            </a:pPr>
-            <a:r>
-              <a:t>• Data drift monitoring (Evidently integration)</a:t>
-            </a:r>
-          </a:p>
-          <a:p>
-            <a:pPr>
-              <a:spcAft>
-                <a:spcPts val="1000"/>
-              </a:spcAft>
-              <a:defRPr sz="2000">
-                <a:solidFill>
-                  <a:srgbClr val="FFFFFF"/>
-                </a:solidFill>
-              </a:defRPr>
-            </a:pPr>
-            <a:r>
-              <a:t>• Multi-user collaboration &amp; dataset versioning (DVC)</a:t>
+              <a:t>$ cd alpha_Hackathon</a:t>
+            </a:r>
+          </a:p>
+          <a:p>
+            <a:pPr>
+              <a:spcAft>
+                <a:spcPts val="1000"/>
+              </a:spcAft>
+              <a:defRPr sz="2000">
+                <a:solidFill>
+                  <a:srgbClr val="FFFFFF"/>
+                </a:solidFill>
+              </a:defRPr>
+            </a:pPr>
+            <a:r>
+              <a:t>$ python3 -m venv venv</a:t>
+            </a:r>
+          </a:p>
+          <a:p>
+            <a:pPr>
+              <a:spcAft>
+                <a:spcPts val="1000"/>
+              </a:spcAft>
+              <a:defRPr sz="2000">
+                <a:solidFill>
+                  <a:srgbClr val="FFFFFF"/>
+                </a:solidFill>
+              </a:defRPr>
+            </a:pPr>
+            <a:r>
+              <a:t>$ source venv/bin/activate</a:t>
+            </a:r>
+          </a:p>
+          <a:p>
+            <a:pPr>
+              <a:spcAft>
+                <a:spcPts val="1000"/>
+              </a:spcAft>
+              <a:defRPr sz="2000">
+                <a:solidFill>
+                  <a:srgbClr val="FFFFFF"/>
+                </a:solidFill>
+              </a:defRPr>
+            </a:pPr>
+            <a:r>
+              <a:t>$ pip install -r requirements.txt</a:t>
+            </a:r>
+          </a:p>
+          <a:p>
+            <a:pPr>
+              <a:spcAft>
+                <a:spcPts val="1000"/>
+              </a:spcAft>
+              <a:defRPr sz="2000">
+                <a:solidFill>
+                  <a:srgbClr val="FFFFFF"/>
+                </a:solidFill>
+              </a:defRPr>
+            </a:pPr>
+            <a:r>
+              <a:t>$ streamlit run app.py</a:t>
+            </a:r>
+          </a:p>
+          <a:p>
+            <a:pPr>
+              <a:spcAft>
+                <a:spcPts val="1000"/>
+              </a:spcAft>
+              <a:defRPr sz="2000">
+                <a:solidFill>
+                  <a:srgbClr val="FFFFFF"/>
+                </a:solidFill>
+              </a:defRPr>
+            </a:pPr>
+          </a:p>
+          <a:p>
+            <a:pPr>
+              <a:spcAft>
+                <a:spcPts val="1000"/>
+              </a:spcAft>
+              <a:defRPr sz="2000">
+                <a:solidFill>
+                  <a:srgbClr val="FFFFFF"/>
+                </a:solidFill>
+              </a:defRPr>
+            </a:pPr>
+            <a:r>
+              <a:t>Then upload sample_data.csv (or any dataset) to start processing!</a:t>
             </a:r>
           </a:p>
         </p:txBody>
@@ -4888,8 +5048,8 @@
         </p:nvSpPr>
         <p:spPr>
           <a:xfrm>
-            <a:off x="914400" y="2286000"/>
-            <a:ext cx="10058400" cy="1828800"/>
+            <a:off x="731520" y="365760"/>
+            <a:ext cx="10058400" cy="914400"/>
           </a:xfrm>
           <a:prstGeom prst="rect">
             <a:avLst/>
@@ -4902,32 +5062,128 @@
           </a:bodyPr>
           <a:lstStyle/>
           <a:p>
-            <a:pPr algn="ctr">
-              <a:defRPr sz="4400" b="1">
-                <a:solidFill>
-                  <a:srgbClr val="FFFFFF"/>
-                </a:solidFill>
-              </a:defRPr>
-            </a:pPr>
-            <a:r>
-              <a:t>Thank You! 🎉</a:t>
-            </a:r>
-          </a:p>
-          <a:p>
-            <a:pPr algn="ctr">
-              <a:defRPr sz="2200">
-                <a:solidFill>
-                  <a:srgbClr val="BAC2DE"/>
-                </a:solidFill>
-              </a:defRPr>
-            </a:pPr>
-            <a:r>
-              <a:t>64 operations • 14 categories • 1 app</a:t>
-            </a:r>
-            <a:br/>
-            <a:br/>
-            <a:r>
-              <a:t>Questions?</a:t>
+            <a:pPr>
+              <a:defRPr sz="3200" b="1">
+                <a:solidFill>
+                  <a:srgbClr val="89B4FA"/>
+                </a:solidFill>
+              </a:defRPr>
+            </a:pPr>
+            <a:r>
+              <a:t>Future Enhancements</a:t>
+            </a:r>
+          </a:p>
+        </p:txBody>
+      </p:sp>
+      <p:sp>
+        <p:nvSpPr>
+          <p:cNvPr id="3" name="TextBox 2"/>
+          <p:cNvSpPr txBox="1"/>
+          <p:nvPr/>
+        </p:nvSpPr>
+        <p:spPr>
+          <a:xfrm>
+            <a:off x="914400" y="1371600"/>
+            <a:ext cx="10058400" cy="5029200"/>
+          </a:xfrm>
+          <a:prstGeom prst="rect">
+            <a:avLst/>
+          </a:prstGeom>
+          <a:noFill/>
+        </p:spPr>
+        <p:txBody>
+          <a:bodyPr wrap="square">
+            <a:spAutoFit/>
+          </a:bodyPr>
+          <a:lstStyle/>
+          <a:p>
+            <a:pPr>
+              <a:spcAft>
+                <a:spcPts val="1000"/>
+              </a:spcAft>
+              <a:defRPr sz="2000">
+                <a:solidFill>
+                  <a:srgbClr val="FFFFFF"/>
+                </a:solidFill>
+              </a:defRPr>
+            </a:pPr>
+            <a:r>
+              <a:t>• Pipeline export — save &amp; replay processing steps as JSON</a:t>
+            </a:r>
+          </a:p>
+          <a:p>
+            <a:pPr>
+              <a:spcAft>
+                <a:spcPts val="1000"/>
+              </a:spcAft>
+              <a:defRPr sz="2000">
+                <a:solidFill>
+                  <a:srgbClr val="FFFFFF"/>
+                </a:solidFill>
+              </a:defRPr>
+            </a:pPr>
+            <a:r>
+              <a:t>• AutoML integration — auto-suggest preprocessing per column type</a:t>
+            </a:r>
+          </a:p>
+          <a:p>
+            <a:pPr>
+              <a:spcAft>
+                <a:spcPts val="1000"/>
+              </a:spcAft>
+              <a:defRPr sz="2000">
+                <a:solidFill>
+                  <a:srgbClr val="FFFFFF"/>
+                </a:solidFill>
+              </a:defRPr>
+            </a:pPr>
+            <a:r>
+              <a:t>• UMAP &amp; Autoencoder for dimensionality reduction</a:t>
+            </a:r>
+          </a:p>
+          <a:p>
+            <a:pPr>
+              <a:spcAft>
+                <a:spcPts val="1000"/>
+              </a:spcAft>
+              <a:defRPr sz="2000">
+                <a:solidFill>
+                  <a:srgbClr val="FFFFFF"/>
+                </a:solidFill>
+              </a:defRPr>
+            </a:pPr>
+            <a:r>
+              <a:t>• NLP: stopword removal, TF-IDF, embeddings</a:t>
+            </a:r>
+          </a:p>
+          <a:p>
+            <a:pPr>
+              <a:spcAft>
+                <a:spcPts val="1000"/>
+              </a:spcAft>
+              <a:defRPr sz="2000">
+                <a:solidFill>
+                  <a:srgbClr val="FFFFFF"/>
+                </a:solidFill>
+              </a:defRPr>
+            </a:pPr>
+            <a:r>
+              <a:t>• Data drift monitoring (Evidently integration)</a:t>
+            </a:r>
+          </a:p>
+          <a:p>
+            <a:pPr>
+              <a:spcAft>
+                <a:spcPts val="1000"/>
+              </a:spcAft>
+              <a:defRPr sz="2000">
+                <a:solidFill>
+                  <a:srgbClr val="FFFFFF"/>
+                </a:solidFill>
+              </a:defRPr>
+            </a:pPr>
+            <a:r>
+              <a:t>• Multi-user collaboration &amp; dataset versioning (DVC)</a:t>
             </a:r>
           </a:p>
         </p:txBody>

</xml_diff>